<commit_message>
added illustrations of the LES plane extraction and HAWC2 box creation
</commit_message>
<xml_diff>
--- a/presentations/wake_aerodynamics_group4.pptx
+++ b/presentations/wake_aerodynamics_group4.pptx
@@ -5,21 +5,24 @@
     <p:sldMasterId id="2147483662" r:id="rId16"/>
   </p:sldMasterIdLst>
   <p:notesMasterIdLst>
-    <p:notesMasterId r:id="rId21"/>
+    <p:notesMasterId r:id="rId24"/>
   </p:notesMasterIdLst>
   <p:handoutMasterIdLst>
-    <p:handoutMasterId r:id="rId22"/>
+    <p:handoutMasterId r:id="rId25"/>
   </p:handoutMasterIdLst>
   <p:sldIdLst>
     <p:sldId id="500" r:id="rId17"/>
     <p:sldId id="502" r:id="rId18"/>
-    <p:sldId id="505" r:id="rId19"/>
-    <p:sldId id="504" r:id="rId20"/>
+    <p:sldId id="506" r:id="rId19"/>
+    <p:sldId id="507" r:id="rId20"/>
+    <p:sldId id="508" r:id="rId21"/>
+    <p:sldId id="505" r:id="rId22"/>
+    <p:sldId id="504" r:id="rId23"/>
   </p:sldIdLst>
   <p:sldSz cx="12190413" cy="6858000"/>
   <p:notesSz cx="6858000" cy="9144000"/>
   <p:custDataLst>
-    <p:tags r:id="rId23"/>
+    <p:tags r:id="rId26"/>
   </p:custDataLst>
   <p:defaultTextStyle>
     <a:defPPr>
@@ -153,6 +156,9 @@
           <p14:sldIdLst>
             <p14:sldId id="500"/>
             <p14:sldId id="502"/>
+            <p14:sldId id="506"/>
+            <p14:sldId id="507"/>
+            <p14:sldId id="508"/>
           </p14:sldIdLst>
         </p14:section>
         <p14:section name="26.10.2026" id="{6BD670E4-1915-4540-9F17-215133EDEC5F}">
@@ -1296,7 +1302,7 @@
             <a:fld id="{C734BB09-483B-4C4B-A5A4-C02A22055B01}" type="slidenum">
               <a:rPr lang="da-DK" smtClean="0"/>
               <a:pPr/>
-              <a:t>3</a:t>
+              <a:t>6</a:t>
             </a:fld>
             <a:endParaRPr lang="da-DK" dirty="0"/>
           </a:p>
@@ -1519,8 +1525,8 @@
           </a:lstStyle>
           <a:p>
             <a:r>
-              <a:rPr lang="en-GB"/>
-              <a:t>Footer</a:t>
+              <a:rPr lang="en-US" sz="800" dirty="0"/>
+              <a:t>A deconstructed comparison of DWM and LES wake aerodynamics</a:t>
             </a:r>
             <a:endParaRPr lang="en-GB" dirty="0"/>
           </a:p>
@@ -2518,10 +2524,10 @@
       </p:sp>
       <p:sp>
         <p:nvSpPr>
-          <p:cNvPr id="5" name="Date Placeholder 4">
+          <p:cNvPr id="7" name="Date Placeholder 9">
             <a:extLst>
               <a:ext uri="{FF2B5EF4-FFF2-40B4-BE49-F238E27FC236}">
-                <a16:creationId xmlns:a16="http://schemas.microsoft.com/office/drawing/2014/main" id="{1B59D9FD-15D8-7961-FF15-3CC2DEAD55DE}"/>
+                <a16:creationId xmlns:a16="http://schemas.microsoft.com/office/drawing/2014/main" id="{EE5436C8-1F12-977F-6ACA-15B788410270}"/>
               </a:ext>
             </a:extLst>
           </p:cNvPr>
@@ -2529,18 +2535,37 @@
             <a:spLocks noGrp="1"/>
           </p:cNvSpPr>
           <p:nvPr>
-            <p:ph type="dt" sz="half" idx="18"/>
+            <p:ph type="dt" sz="half" idx="2"/>
           </p:nvPr>
         </p:nvSpPr>
-        <p:spPr/>
+        <p:spPr>
+          <a:xfrm>
+            <a:off x="217598" y="6517037"/>
+            <a:ext cx="733317" cy="365125"/>
+          </a:xfrm>
+          <a:prstGeom prst="rect">
+            <a:avLst/>
+          </a:prstGeom>
+        </p:spPr>
         <p:txBody>
-          <a:bodyPr/>
-          <a:lstStyle/>
-          <a:p>
-            <a:r>
-              <a:rPr lang="en-GB"/>
-              <a:t>Date</a:t>
-            </a:r>
+          <a:bodyPr vert="horz" lIns="91440" tIns="45720" rIns="91440" bIns="45720" rtlCol="0" anchor="ctr"/>
+          <a:lstStyle>
+            <a:lvl1pPr algn="l">
+              <a:defRPr sz="800">
+                <a:solidFill>
+                  <a:schemeClr val="bg1"/>
+                </a:solidFill>
+                <a:latin typeface="+mn-lt"/>
+              </a:defRPr>
+            </a:lvl1pPr>
+          </a:lstStyle>
+          <a:p>
+            <a:fld id="{3DF5C358-002F-4FFE-AE51-8D3FBE9A7FC8}" type="datetimeFigureOut">
+              <a:rPr lang="en-US" smtClean="0"/>
+              <a:pPr/>
+              <a:t>10/6/2026</a:t>
+            </a:fld>
+            <a:endParaRPr lang="en-US" dirty="0"/>
           </a:p>
         </p:txBody>
       </p:sp>
@@ -5129,8 +5154,8 @@
           <a:lstStyle/>
           <a:p>
             <a:r>
-              <a:rPr lang="en-GB"/>
-              <a:t>Footer</a:t>
+              <a:rPr lang="en-US" sz="800" dirty="0"/>
+              <a:t>A deconstructed comparison of DWM and LES wake aerodynamics</a:t>
             </a:r>
             <a:endParaRPr lang="en-GB" dirty="0"/>
           </a:p>
@@ -5176,10 +5201,10 @@
       </p:sp>
       <p:sp>
         <p:nvSpPr>
-          <p:cNvPr id="2" name="Date Placeholder 1">
+          <p:cNvPr id="5" name="Date Placeholder 9">
             <a:extLst>
               <a:ext uri="{FF2B5EF4-FFF2-40B4-BE49-F238E27FC236}">
-                <a16:creationId xmlns:a16="http://schemas.microsoft.com/office/drawing/2014/main" id="{0C081365-8ADF-38B5-60FB-FC504490ABEE}"/>
+                <a16:creationId xmlns:a16="http://schemas.microsoft.com/office/drawing/2014/main" id="{04D2BAA8-A563-0D13-D225-ABE2D961C3CC}"/>
               </a:ext>
             </a:extLst>
           </p:cNvPr>
@@ -5187,18 +5212,37 @@
             <a:spLocks noGrp="1"/>
           </p:cNvSpPr>
           <p:nvPr>
-            <p:ph type="dt" sz="half" idx="18"/>
+            <p:ph type="dt" sz="half" idx="2"/>
           </p:nvPr>
         </p:nvSpPr>
-        <p:spPr/>
+        <p:spPr>
+          <a:xfrm>
+            <a:off x="217598" y="6517037"/>
+            <a:ext cx="733317" cy="365125"/>
+          </a:xfrm>
+          <a:prstGeom prst="rect">
+            <a:avLst/>
+          </a:prstGeom>
+        </p:spPr>
         <p:txBody>
-          <a:bodyPr/>
-          <a:lstStyle/>
-          <a:p>
-            <a:r>
-              <a:rPr lang="en-GB"/>
-              <a:t>Date</a:t>
-            </a:r>
+          <a:bodyPr vert="horz" lIns="91440" tIns="45720" rIns="91440" bIns="45720" rtlCol="0" anchor="ctr"/>
+          <a:lstStyle>
+            <a:lvl1pPr algn="l">
+              <a:defRPr sz="800">
+                <a:solidFill>
+                  <a:schemeClr val="bg1"/>
+                </a:solidFill>
+                <a:latin typeface="+mn-lt"/>
+              </a:defRPr>
+            </a:lvl1pPr>
+          </a:lstStyle>
+          <a:p>
+            <a:fld id="{3DF5C358-002F-4FFE-AE51-8D3FBE9A7FC8}" type="datetimeFigureOut">
+              <a:rPr lang="en-US" smtClean="0"/>
+              <a:pPr/>
+              <a:t>10/6/2026</a:t>
+            </a:fld>
+            <a:endParaRPr lang="en-US" dirty="0"/>
           </a:p>
         </p:txBody>
       </p:sp>
@@ -5351,8 +5395,8 @@
           <a:lstStyle/>
           <a:p>
             <a:r>
-              <a:rPr lang="en-GB"/>
-              <a:t>Footer</a:t>
+              <a:rPr lang="en-US" sz="800" dirty="0"/>
+              <a:t>A deconstructed comparison of DWM and LES wake aerodynamics</a:t>
             </a:r>
             <a:endParaRPr lang="en-GB" dirty="0"/>
           </a:p>
@@ -5390,10 +5434,10 @@
       </p:sp>
       <p:sp>
         <p:nvSpPr>
-          <p:cNvPr id="4" name="Date Placeholder 3">
+          <p:cNvPr id="5" name="Date Placeholder 9">
             <a:extLst>
               <a:ext uri="{FF2B5EF4-FFF2-40B4-BE49-F238E27FC236}">
-                <a16:creationId xmlns:a16="http://schemas.microsoft.com/office/drawing/2014/main" id="{887C07BA-32CB-B6FD-0167-0426D7F6C114}"/>
+                <a16:creationId xmlns:a16="http://schemas.microsoft.com/office/drawing/2014/main" id="{58AEF35A-E6D5-9E5B-1FD2-C76BEEFC1176}"/>
               </a:ext>
             </a:extLst>
           </p:cNvPr>
@@ -5401,18 +5445,37 @@
             <a:spLocks noGrp="1"/>
           </p:cNvSpPr>
           <p:nvPr>
-            <p:ph type="dt" sz="half" idx="12"/>
+            <p:ph type="dt" sz="half" idx="2"/>
           </p:nvPr>
         </p:nvSpPr>
-        <p:spPr/>
+        <p:spPr>
+          <a:xfrm>
+            <a:off x="217598" y="6517037"/>
+            <a:ext cx="733317" cy="365125"/>
+          </a:xfrm>
+          <a:prstGeom prst="rect">
+            <a:avLst/>
+          </a:prstGeom>
+        </p:spPr>
         <p:txBody>
-          <a:bodyPr/>
-          <a:lstStyle/>
-          <a:p>
-            <a:r>
-              <a:rPr lang="en-GB"/>
-              <a:t>Date</a:t>
-            </a:r>
+          <a:bodyPr vert="horz" lIns="91440" tIns="45720" rIns="91440" bIns="45720" rtlCol="0" anchor="ctr"/>
+          <a:lstStyle>
+            <a:lvl1pPr algn="l">
+              <a:defRPr sz="800">
+                <a:solidFill>
+                  <a:schemeClr val="bg1"/>
+                </a:solidFill>
+                <a:latin typeface="+mn-lt"/>
+              </a:defRPr>
+            </a:lvl1pPr>
+          </a:lstStyle>
+          <a:p>
+            <a:fld id="{3DF5C358-002F-4FFE-AE51-8D3FBE9A7FC8}" type="datetimeFigureOut">
+              <a:rPr lang="en-US" smtClean="0"/>
+              <a:pPr/>
+              <a:t>10/6/2026</a:t>
+            </a:fld>
+            <a:endParaRPr lang="en-US" dirty="0"/>
           </a:p>
         </p:txBody>
       </p:sp>
@@ -5688,10 +5751,9 @@
           <a:lstStyle/>
           <a:p>
             <a:r>
-              <a:rPr lang="en-GB"/>
+              <a:rPr lang="en-GB" dirty="0"/>
               <a:t>Footer</a:t>
             </a:r>
-            <a:endParaRPr lang="en-GB" dirty="0"/>
           </a:p>
         </p:txBody>
       </p:sp>
@@ -5741,7 +5803,15 @@
             <p:ph type="dt" sz="half" idx="12"/>
           </p:nvPr>
         </p:nvSpPr>
-        <p:spPr/>
+        <p:spPr>
+          <a:xfrm>
+            <a:off x="252000" y="6541200"/>
+            <a:ext cx="1105200" cy="316800"/>
+          </a:xfrm>
+          <a:prstGeom prst="rect">
+            <a:avLst/>
+          </a:prstGeom>
+        </p:spPr>
         <p:txBody>
           <a:bodyPr/>
           <a:lstStyle/>
@@ -6056,7 +6126,15 @@
             <p:ph type="dt" sz="half" idx="17"/>
           </p:nvPr>
         </p:nvSpPr>
-        <p:spPr/>
+        <p:spPr>
+          <a:xfrm>
+            <a:off x="252000" y="6541200"/>
+            <a:ext cx="1105200" cy="316800"/>
+          </a:xfrm>
+          <a:prstGeom prst="rect">
+            <a:avLst/>
+          </a:prstGeom>
+        </p:spPr>
         <p:txBody>
           <a:bodyPr/>
           <a:lstStyle/>
@@ -6366,7 +6444,15 @@
             <p:ph type="dt" sz="half" idx="17"/>
           </p:nvPr>
         </p:nvSpPr>
-        <p:spPr/>
+        <p:spPr>
+          <a:xfrm>
+            <a:off x="252000" y="6541200"/>
+            <a:ext cx="1105200" cy="316800"/>
+          </a:xfrm>
+          <a:prstGeom prst="rect">
+            <a:avLst/>
+          </a:prstGeom>
+        </p:spPr>
         <p:txBody>
           <a:bodyPr/>
           <a:lstStyle/>
@@ -7057,7 +7143,15 @@
             <p:ph type="dt" sz="half" idx="25"/>
           </p:nvPr>
         </p:nvSpPr>
-        <p:spPr/>
+        <p:spPr>
+          <a:xfrm>
+            <a:off x="252000" y="6541200"/>
+            <a:ext cx="1105200" cy="316800"/>
+          </a:xfrm>
+          <a:prstGeom prst="rect">
+            <a:avLst/>
+          </a:prstGeom>
+        </p:spPr>
         <p:txBody>
           <a:bodyPr/>
           <a:lstStyle/>
@@ -7166,8 +7260,8 @@
           <a:lstStyle/>
           <a:p>
             <a:r>
-              <a:rPr lang="en-GB"/>
-              <a:t>Footer</a:t>
+              <a:rPr lang="en-US" sz="800" dirty="0"/>
+              <a:t>A deconstructed comparison of DWM and LES wake aerodynamics</a:t>
             </a:r>
             <a:endParaRPr lang="en-GB" dirty="0"/>
           </a:p>
@@ -7205,10 +7299,10 @@
       </p:sp>
       <p:sp>
         <p:nvSpPr>
-          <p:cNvPr id="3" name="Date Placeholder 2">
+          <p:cNvPr id="4" name="Date Placeholder 9">
             <a:extLst>
               <a:ext uri="{FF2B5EF4-FFF2-40B4-BE49-F238E27FC236}">
-                <a16:creationId xmlns:a16="http://schemas.microsoft.com/office/drawing/2014/main" id="{E10ACE46-7CDE-36FE-2F3D-4211E75A4880}"/>
+                <a16:creationId xmlns:a16="http://schemas.microsoft.com/office/drawing/2014/main" id="{781DC4C9-7CE1-1E20-D42A-C8AB14F1194E}"/>
               </a:ext>
             </a:extLst>
           </p:cNvPr>
@@ -7216,18 +7310,37 @@
             <a:spLocks noGrp="1"/>
           </p:cNvSpPr>
           <p:nvPr>
-            <p:ph type="dt" sz="half" idx="12"/>
+            <p:ph type="dt" sz="half" idx="2"/>
           </p:nvPr>
         </p:nvSpPr>
-        <p:spPr/>
+        <p:spPr>
+          <a:xfrm>
+            <a:off x="217598" y="6517037"/>
+            <a:ext cx="733317" cy="365125"/>
+          </a:xfrm>
+          <a:prstGeom prst="rect">
+            <a:avLst/>
+          </a:prstGeom>
+        </p:spPr>
         <p:txBody>
-          <a:bodyPr/>
-          <a:lstStyle/>
-          <a:p>
-            <a:r>
-              <a:rPr lang="en-GB"/>
-              <a:t>Date</a:t>
-            </a:r>
+          <a:bodyPr vert="horz" lIns="91440" tIns="45720" rIns="91440" bIns="45720" rtlCol="0" anchor="ctr"/>
+          <a:lstStyle>
+            <a:lvl1pPr algn="l">
+              <a:defRPr sz="800">
+                <a:solidFill>
+                  <a:schemeClr val="bg1"/>
+                </a:solidFill>
+                <a:latin typeface="+mn-lt"/>
+              </a:defRPr>
+            </a:lvl1pPr>
+          </a:lstStyle>
+          <a:p>
+            <a:fld id="{3DF5C358-002F-4FFE-AE51-8D3FBE9A7FC8}" type="datetimeFigureOut">
+              <a:rPr lang="en-US" smtClean="0"/>
+              <a:pPr/>
+              <a:t>10/6/2026</a:t>
+            </a:fld>
+            <a:endParaRPr lang="en-US" dirty="0"/>
           </a:p>
         </p:txBody>
       </p:sp>
@@ -7299,8 +7412,8 @@
           <a:lstStyle/>
           <a:p>
             <a:r>
-              <a:rPr lang="en-GB"/>
-              <a:t>Footer</a:t>
+              <a:rPr lang="en-US" sz="800" dirty="0"/>
+              <a:t>A deconstructed comparison of DWM and LES wake aerodynamics</a:t>
             </a:r>
             <a:endParaRPr lang="en-GB" dirty="0"/>
           </a:p>
@@ -7338,10 +7451,10 @@
       </p:sp>
       <p:sp>
         <p:nvSpPr>
-          <p:cNvPr id="2" name="Date Placeholder 1">
+          <p:cNvPr id="3" name="Date Placeholder 9">
             <a:extLst>
               <a:ext uri="{FF2B5EF4-FFF2-40B4-BE49-F238E27FC236}">
-                <a16:creationId xmlns:a16="http://schemas.microsoft.com/office/drawing/2014/main" id="{625A548B-56FD-2AAD-2E9D-6703F282FCC3}"/>
+                <a16:creationId xmlns:a16="http://schemas.microsoft.com/office/drawing/2014/main" id="{279C4567-9491-70D1-2F1E-9C21CE63FEF4}"/>
               </a:ext>
             </a:extLst>
           </p:cNvPr>
@@ -7349,18 +7462,37 @@
             <a:spLocks noGrp="1"/>
           </p:cNvSpPr>
           <p:nvPr>
-            <p:ph type="dt" sz="half" idx="12"/>
+            <p:ph type="dt" sz="half" idx="2"/>
           </p:nvPr>
         </p:nvSpPr>
-        <p:spPr/>
+        <p:spPr>
+          <a:xfrm>
+            <a:off x="217598" y="6517037"/>
+            <a:ext cx="733317" cy="365125"/>
+          </a:xfrm>
+          <a:prstGeom prst="rect">
+            <a:avLst/>
+          </a:prstGeom>
+        </p:spPr>
         <p:txBody>
-          <a:bodyPr/>
-          <a:lstStyle/>
-          <a:p>
-            <a:r>
-              <a:rPr lang="en-GB"/>
-              <a:t>Date</a:t>
-            </a:r>
+          <a:bodyPr vert="horz" lIns="91440" tIns="45720" rIns="91440" bIns="45720" rtlCol="0" anchor="ctr"/>
+          <a:lstStyle>
+            <a:lvl1pPr algn="l">
+              <a:defRPr sz="800">
+                <a:solidFill>
+                  <a:schemeClr val="bg1"/>
+                </a:solidFill>
+                <a:latin typeface="+mn-lt"/>
+              </a:defRPr>
+            </a:lvl1pPr>
+          </a:lstStyle>
+          <a:p>
+            <a:fld id="{3DF5C358-002F-4FFE-AE51-8D3FBE9A7FC8}" type="datetimeFigureOut">
+              <a:rPr lang="en-US" smtClean="0"/>
+              <a:pPr/>
+              <a:t>10/6/2026</a:t>
+            </a:fld>
+            <a:endParaRPr lang="en-US" dirty="0"/>
           </a:p>
         </p:txBody>
       </p:sp>
@@ -7574,8 +7706,8 @@
           </a:lstStyle>
           <a:p>
             <a:r>
-              <a:rPr lang="en-GB" dirty="0"/>
-              <a:t>Footer</a:t>
+              <a:rPr lang="en-US" dirty="0"/>
+              <a:t>A deconstructed comparison of DWM and LES wake aerodynamics</a:t>
             </a:r>
           </a:p>
         </p:txBody>
@@ -7959,7 +8091,7 @@
                 </a:solidFill>
                 <a:latin typeface="+mn-lt"/>
               </a:rPr>
-              <a:t>[Division / Section]</a:t>
+              <a:t>Wake Aerodynamics special course</a:t>
             </a:r>
           </a:p>
         </p:txBody>
@@ -8918,10 +9050,60 @@
       </p:sp>
       <p:sp>
         <p:nvSpPr>
-          <p:cNvPr id="5" name="Date Placeholder 4">
+          <p:cNvPr id="9" name="TextBox 8">
             <a:extLst>
               <a:ext uri="{FF2B5EF4-FFF2-40B4-BE49-F238E27FC236}">
-                <a16:creationId xmlns:a16="http://schemas.microsoft.com/office/drawing/2014/main" id="{5C4F905E-0728-756C-E812-6B8FBD431623}"/>
+                <a16:creationId xmlns:a16="http://schemas.microsoft.com/office/drawing/2014/main" id="{3073EFAB-325B-97BA-DE6F-468FFDFA2FDF}"/>
+              </a:ext>
+            </a:extLst>
+          </p:cNvPr>
+          <p:cNvSpPr txBox="1"/>
+          <p:nvPr>
+            <p:extLst>
+              <p:ext uri="{1162E1C5-73C7-4A58-AE30-91384D911F3F}">
+                <p184:classification xmlns:p184="http://schemas.microsoft.com/office/powerpoint/2018/4/main" val="ftr"/>
+              </p:ext>
+            </p:extLst>
+          </p:nvPr>
+        </p:nvSpPr>
+        <p:spPr>
+          <a:xfrm>
+            <a:off x="5627688" y="6306820"/>
+            <a:ext cx="963612" cy="487680"/>
+          </a:xfrm>
+          <a:prstGeom prst="rect">
+            <a:avLst/>
+          </a:prstGeom>
+        </p:spPr>
+        <p:txBody>
+          <a:bodyPr horzOverflow="overflow" lIns="0" tIns="0" rIns="0" bIns="0">
+            <a:spAutoFit/>
+          </a:bodyPr>
+          <a:lstStyle/>
+          <a:p>
+            <a:pPr algn="l"/>
+            <a:r>
+              <a:rPr lang="en-US" sz="800" dirty="0">
+                <a:solidFill>
+                  <a:srgbClr val="37424A">
+                    <a:alpha val="50000"/>
+                  </a:srgbClr>
+                </a:solidFill>
+                <a:latin typeface="Arial" panose="020B0604020202020204" pitchFamily="34" charset="0"/>
+                <a:cs typeface="Arial" panose="020B0604020202020204" pitchFamily="34" charset="0"/>
+              </a:rPr>
+              <a:t>Classification: Public
+</a:t>
+            </a:r>
+          </a:p>
+        </p:txBody>
+      </p:sp>
+      <p:sp>
+        <p:nvSpPr>
+          <p:cNvPr id="10" name="Date Placeholder 9">
+            <a:extLst>
+              <a:ext uri="{FF2B5EF4-FFF2-40B4-BE49-F238E27FC236}">
+                <a16:creationId xmlns:a16="http://schemas.microsoft.com/office/drawing/2014/main" id="{D6EF3636-3D89-3F5C-0EAA-69D15CF748D3}"/>
               </a:ext>
             </a:extLst>
           </p:cNvPr>
@@ -8934,8 +9116,8 @@
         </p:nvSpPr>
         <p:spPr>
           <a:xfrm>
-            <a:off x="252000" y="6541200"/>
-            <a:ext cx="1105200" cy="316800"/>
+            <a:off x="217598" y="6517037"/>
+            <a:ext cx="733317" cy="365125"/>
           </a:xfrm>
           <a:prstGeom prst="rect">
             <a:avLst/>
@@ -8945,67 +9127,21 @@
           <a:bodyPr vert="horz" lIns="91440" tIns="45720" rIns="91440" bIns="45720" rtlCol="0" anchor="ctr"/>
           <a:lstStyle>
             <a:lvl1pPr algn="l">
-              <a:defRPr sz="700" b="1">
+              <a:defRPr sz="800">
                 <a:solidFill>
-                  <a:srgbClr val="FFFFFF"/>
+                  <a:schemeClr val="bg1"/>
                 </a:solidFill>
-                <a:latin typeface="+mj-lt"/>
+                <a:latin typeface="+mn-lt"/>
               </a:defRPr>
             </a:lvl1pPr>
           </a:lstStyle>
           <a:p>
-            <a:r>
-              <a:rPr lang="en-GB" dirty="0"/>
-              <a:t>Date</a:t>
-            </a:r>
-          </a:p>
-        </p:txBody>
-      </p:sp>
-      <p:sp>
-        <p:nvSpPr>
-          <p:cNvPr id="9" name="TextBox 8">
-            <a:extLst>
-              <a:ext uri="{FF2B5EF4-FFF2-40B4-BE49-F238E27FC236}">
-                <a16:creationId xmlns:a16="http://schemas.microsoft.com/office/drawing/2014/main" id="{3073EFAB-325B-97BA-DE6F-468FFDFA2FDF}"/>
-              </a:ext>
-            </a:extLst>
-          </p:cNvPr>
-          <p:cNvSpPr txBox="1"/>
-          <p:nvPr userDrawn="1">
-            <p:extLst>
-              <p:ext uri="{1162E1C5-73C7-4A58-AE30-91384D911F3F}">
-                <p184:classification xmlns:p184="http://schemas.microsoft.com/office/powerpoint/2018/4/main" val="ftr"/>
-              </p:ext>
-            </p:extLst>
-          </p:nvPr>
-        </p:nvSpPr>
-        <p:spPr>
-          <a:xfrm>
-            <a:off x="5499100" y="6672580"/>
-            <a:ext cx="1212850" cy="121920"/>
-          </a:xfrm>
-          <a:prstGeom prst="rect">
-            <a:avLst/>
-          </a:prstGeom>
-        </p:spPr>
-        <p:txBody>
-          <a:bodyPr horzOverflow="overflow" lIns="0" tIns="0" rIns="0" bIns="0">
-            <a:spAutoFit/>
-          </a:bodyPr>
-          <a:lstStyle/>
-          <a:p>
-            <a:pPr algn="l"/>
-            <a:r>
-              <a:rPr lang="en-US" sz="800">
-                <a:solidFill>
-                  <a:srgbClr val="000000">
-                    <a:alpha val="50000"/>
-                  </a:srgbClr>
-                </a:solidFill>
-                <a:latin typeface="Aptos" panose="020B0004020202020204" pitchFamily="34" charset="0"/>
-              </a:rPr>
-              <a:t>Classification: Confidential</a:t>
-            </a:r>
+            <a:fld id="{3DF5C358-002F-4FFE-AE51-8D3FBE9A7FC8}" type="datetimeFigureOut">
+              <a:rPr lang="en-US" smtClean="0"/>
+              <a:pPr/>
+              <a:t>10/6/2026</a:t>
+            </a:fld>
+            <a:endParaRPr lang="en-US" dirty="0"/>
           </a:p>
         </p:txBody>
       </p:sp>
@@ -9590,8 +9726,8 @@
           <a:lstStyle/>
           <a:p>
             <a:r>
-              <a:rPr lang="en-GB"/>
-              <a:t>Footer</a:t>
+              <a:rPr lang="en-US" sz="800" dirty="0"/>
+              <a:t>A deconstructed comparison of DWM and LES wake aerodynamics</a:t>
             </a:r>
             <a:endParaRPr lang="en-GB" dirty="0"/>
           </a:p>
@@ -9874,34 +10010,6 @@
                 <a:schemeClr val="accent6"/>
               </a:solidFill>
             </a:endParaRPr>
-          </a:p>
-        </p:txBody>
-      </p:sp>
-      <p:sp>
-        <p:nvSpPr>
-          <p:cNvPr id="4" name="Date Placeholder 3">
-            <a:extLst>
-              <a:ext uri="{FF2B5EF4-FFF2-40B4-BE49-F238E27FC236}">
-                <a16:creationId xmlns:a16="http://schemas.microsoft.com/office/drawing/2014/main" id="{CF8680AE-A2C5-C08E-39DD-39DA08E5D251}"/>
-              </a:ext>
-            </a:extLst>
-          </p:cNvPr>
-          <p:cNvSpPr>
-            <a:spLocks noGrp="1"/>
-          </p:cNvSpPr>
-          <p:nvPr>
-            <p:ph type="dt" sz="half" idx="18"/>
-          </p:nvPr>
-        </p:nvSpPr>
-        <p:spPr/>
-        <p:txBody>
-          <a:bodyPr/>
-          <a:lstStyle/>
-          <a:p>
-            <a:r>
-              <a:rPr lang="en-GB"/>
-              <a:t>Date</a:t>
-            </a:r>
           </a:p>
         </p:txBody>
       </p:sp>
@@ -10141,6 +10249,53 @@
           </a:p>
         </p:txBody>
       </p:sp>
+      <p:sp>
+        <p:nvSpPr>
+          <p:cNvPr id="9" name="Date Placeholder 9">
+            <a:extLst>
+              <a:ext uri="{FF2B5EF4-FFF2-40B4-BE49-F238E27FC236}">
+                <a16:creationId xmlns:a16="http://schemas.microsoft.com/office/drawing/2014/main" id="{09FD4E48-665B-257B-23D0-0BD33FB9FA97}"/>
+              </a:ext>
+            </a:extLst>
+          </p:cNvPr>
+          <p:cNvSpPr>
+            <a:spLocks noGrp="1"/>
+          </p:cNvSpPr>
+          <p:nvPr>
+            <p:ph type="dt" sz="half" idx="2"/>
+          </p:nvPr>
+        </p:nvSpPr>
+        <p:spPr>
+          <a:xfrm>
+            <a:off x="217598" y="6517037"/>
+            <a:ext cx="733317" cy="365125"/>
+          </a:xfrm>
+          <a:prstGeom prst="rect">
+            <a:avLst/>
+          </a:prstGeom>
+        </p:spPr>
+        <p:txBody>
+          <a:bodyPr vert="horz" lIns="91440" tIns="45720" rIns="91440" bIns="45720" rtlCol="0" anchor="ctr"/>
+          <a:lstStyle>
+            <a:lvl1pPr algn="l">
+              <a:defRPr sz="800">
+                <a:solidFill>
+                  <a:schemeClr val="bg1"/>
+                </a:solidFill>
+                <a:latin typeface="+mn-lt"/>
+              </a:defRPr>
+            </a:lvl1pPr>
+          </a:lstStyle>
+          <a:p>
+            <a:fld id="{3DF5C358-002F-4FFE-AE51-8D3FBE9A7FC8}" type="datetimeFigureOut">
+              <a:rPr lang="en-US" smtClean="0"/>
+              <a:pPr/>
+              <a:t>10/6/2026</a:t>
+            </a:fld>
+            <a:endParaRPr lang="en-US" dirty="0"/>
+          </a:p>
+        </p:txBody>
+      </p:sp>
     </p:spTree>
     <p:custDataLst>
       <p:custData r:id="rId1"/>
@@ -10331,8 +10486,8 @@
           <a:lstStyle/>
           <a:p>
             <a:r>
-              <a:rPr lang="en-GB"/>
-              <a:t>Footer</a:t>
+              <a:rPr lang="en-US" sz="800" dirty="0"/>
+              <a:t>A deconstructed comparison of DWM and LES wake aerodynamics</a:t>
             </a:r>
             <a:endParaRPr lang="en-GB" dirty="0"/>
           </a:p>
@@ -10370,10 +10525,10 @@
       </p:sp>
       <p:sp>
         <p:nvSpPr>
-          <p:cNvPr id="6" name="Date Placeholder 5">
+          <p:cNvPr id="8" name="Date Placeholder 9">
             <a:extLst>
               <a:ext uri="{FF2B5EF4-FFF2-40B4-BE49-F238E27FC236}">
-                <a16:creationId xmlns:a16="http://schemas.microsoft.com/office/drawing/2014/main" id="{1E51429E-A974-AACC-647E-13C29E161575}"/>
+                <a16:creationId xmlns:a16="http://schemas.microsoft.com/office/drawing/2014/main" id="{C4FBA9DD-1247-F71B-E142-CB0D7681ADBA}"/>
               </a:ext>
             </a:extLst>
           </p:cNvPr>
@@ -10381,18 +10536,37 @@
             <a:spLocks noGrp="1"/>
           </p:cNvSpPr>
           <p:nvPr>
-            <p:ph type="dt" sz="half" idx="12"/>
+            <p:ph type="dt" sz="half" idx="2"/>
           </p:nvPr>
         </p:nvSpPr>
-        <p:spPr/>
+        <p:spPr>
+          <a:xfrm>
+            <a:off x="217598" y="6517037"/>
+            <a:ext cx="733317" cy="365125"/>
+          </a:xfrm>
+          <a:prstGeom prst="rect">
+            <a:avLst/>
+          </a:prstGeom>
+        </p:spPr>
         <p:txBody>
-          <a:bodyPr/>
-          <a:lstStyle/>
-          <a:p>
-            <a:r>
-              <a:rPr lang="en-GB"/>
-              <a:t>Date</a:t>
-            </a:r>
+          <a:bodyPr vert="horz" lIns="91440" tIns="45720" rIns="91440" bIns="45720" rtlCol="0" anchor="ctr"/>
+          <a:lstStyle>
+            <a:lvl1pPr algn="l">
+              <a:defRPr sz="800">
+                <a:solidFill>
+                  <a:schemeClr val="bg1"/>
+                </a:solidFill>
+                <a:latin typeface="+mn-lt"/>
+              </a:defRPr>
+            </a:lvl1pPr>
+          </a:lstStyle>
+          <a:p>
+            <a:fld id="{3DF5C358-002F-4FFE-AE51-8D3FBE9A7FC8}" type="datetimeFigureOut">
+              <a:rPr lang="en-US" smtClean="0"/>
+              <a:pPr/>
+              <a:t>10/6/2026</a:t>
+            </a:fld>
+            <a:endParaRPr lang="en-US" dirty="0"/>
           </a:p>
         </p:txBody>
       </p:sp>
@@ -10410,6 +10584,624 @@
 </file>
 
 <file path=ppt/slides/slide3.xml><?xml version="1.0" encoding="utf-8"?>
+<p:sld xmlns:a="http://schemas.openxmlformats.org/drawingml/2006/main" xmlns:r="http://schemas.openxmlformats.org/officeDocument/2006/relationships" xmlns:p="http://schemas.openxmlformats.org/presentationml/2006/main">
+  <p:cSld>
+    <p:spTree>
+      <p:nvGrpSpPr>
+        <p:cNvPr id="1" name=""/>
+        <p:cNvGrpSpPr/>
+        <p:nvPr/>
+      </p:nvGrpSpPr>
+      <p:grpSpPr>
+        <a:xfrm>
+          <a:off x="0" y="0"/>
+          <a:ext cx="0" cy="0"/>
+          <a:chOff x="0" y="0"/>
+          <a:chExt cx="0" cy="0"/>
+        </a:xfrm>
+      </p:grpSpPr>
+      <p:sp>
+        <p:nvSpPr>
+          <p:cNvPr id="16" name="Title 1">
+            <a:extLst>
+              <a:ext uri="{FF2B5EF4-FFF2-40B4-BE49-F238E27FC236}">
+                <a16:creationId xmlns:a16="http://schemas.microsoft.com/office/drawing/2014/main" id="{47488D8A-FD9D-A3E2-0B4D-4ED61146D259}"/>
+              </a:ext>
+            </a:extLst>
+          </p:cNvPr>
+          <p:cNvSpPr>
+            <a:spLocks noGrp="1"/>
+          </p:cNvSpPr>
+          <p:nvPr>
+            <p:ph type="title"/>
+          </p:nvPr>
+        </p:nvSpPr>
+        <p:spPr>
+          <a:xfrm>
+            <a:off x="1774726" y="885647"/>
+            <a:ext cx="9312374" cy="513195"/>
+          </a:xfrm>
+        </p:spPr>
+        <p:txBody>
+          <a:bodyPr/>
+          <a:lstStyle/>
+          <a:p>
+            <a:endParaRPr lang="en-US"/>
+          </a:p>
+        </p:txBody>
+      </p:sp>
+      <p:sp>
+        <p:nvSpPr>
+          <p:cNvPr id="4" name="Footer Placeholder 3">
+            <a:extLst>
+              <a:ext uri="{FF2B5EF4-FFF2-40B4-BE49-F238E27FC236}">
+                <a16:creationId xmlns:a16="http://schemas.microsoft.com/office/drawing/2014/main" id="{AC039CF2-45DE-5432-1414-79802D7E850C}"/>
+              </a:ext>
+            </a:extLst>
+          </p:cNvPr>
+          <p:cNvSpPr>
+            <a:spLocks noGrp="1"/>
+          </p:cNvSpPr>
+          <p:nvPr>
+            <p:ph type="ftr" sz="quarter" idx="10"/>
+          </p:nvPr>
+        </p:nvSpPr>
+        <p:spPr>
+          <a:xfrm>
+            <a:off x="4787466" y="6541200"/>
+            <a:ext cx="3286894" cy="316800"/>
+          </a:xfrm>
+        </p:spPr>
+        <p:txBody>
+          <a:bodyPr anchor="ctr">
+            <a:normAutofit/>
+          </a:bodyPr>
+          <a:lstStyle/>
+          <a:p>
+            <a:pPr>
+              <a:spcAft>
+                <a:spcPts val="600"/>
+              </a:spcAft>
+            </a:pPr>
+            <a:r>
+              <a:rPr lang="en-US" sz="800" dirty="0"/>
+              <a:t>A deconstructed comparison of DWM and LES wake aerodynamics</a:t>
+            </a:r>
+            <a:endParaRPr lang="en-GB" dirty="0"/>
+          </a:p>
+        </p:txBody>
+      </p:sp>
+      <p:sp>
+        <p:nvSpPr>
+          <p:cNvPr id="5" name="Slide Number Placeholder 4">
+            <a:extLst>
+              <a:ext uri="{FF2B5EF4-FFF2-40B4-BE49-F238E27FC236}">
+                <a16:creationId xmlns:a16="http://schemas.microsoft.com/office/drawing/2014/main" id="{6EFE0B0B-AAB4-C020-BDFB-8F6380B68AE9}"/>
+              </a:ext>
+            </a:extLst>
+          </p:cNvPr>
+          <p:cNvSpPr>
+            <a:spLocks noGrp="1"/>
+          </p:cNvSpPr>
+          <p:nvPr>
+            <p:ph type="sldNum" sz="quarter" idx="11"/>
+          </p:nvPr>
+        </p:nvSpPr>
+        <p:spPr>
+          <a:xfrm>
+            <a:off x="11506450" y="6541200"/>
+            <a:ext cx="432600" cy="316800"/>
+          </a:xfrm>
+        </p:spPr>
+        <p:txBody>
+          <a:bodyPr anchor="ctr">
+            <a:normAutofit/>
+          </a:bodyPr>
+          <a:lstStyle/>
+          <a:p>
+            <a:fld id="{103EA872-A674-449B-A120-B97244F8E91D}" type="slidenum">
+              <a:rPr lang="en-GB" smtClean="0"/>
+              <a:pPr/>
+              <a:t>3</a:t>
+            </a:fld>
+            <a:endParaRPr lang="en-GB" dirty="0"/>
+          </a:p>
+        </p:txBody>
+      </p:sp>
+      <p:pic>
+        <p:nvPicPr>
+          <p:cNvPr id="22" name="Content Placeholder 21">
+            <a:extLst>
+              <a:ext uri="{FF2B5EF4-FFF2-40B4-BE49-F238E27FC236}">
+                <a16:creationId xmlns:a16="http://schemas.microsoft.com/office/drawing/2014/main" id="{41B0FF26-B205-9AAD-A80E-C8C015796896}"/>
+              </a:ext>
+            </a:extLst>
+          </p:cNvPr>
+          <p:cNvPicPr>
+            <a:picLocks noGrp="1" noChangeAspect="1"/>
+          </p:cNvPicPr>
+          <p:nvPr>
+            <p:ph idx="1"/>
+          </p:nvPr>
+        </p:nvPicPr>
+        <p:blipFill>
+          <a:blip>
+            <a:extLst>
+              <a:ext uri="{96DAC541-7B7A-43D3-8B79-37D633B846F1}">
+                <asvg:svgBlip xmlns:asvg="http://schemas.microsoft.com/office/drawing/2016/SVG/main" r:embed="rId2"/>
+              </a:ext>
+            </a:extLst>
+          </a:blip>
+          <a:stretch>
+            <a:fillRect/>
+          </a:stretch>
+        </p:blipFill>
+        <p:spPr bwMode="auto">
+          <a:xfrm>
+            <a:off x="1774825" y="2233017"/>
+            <a:ext cx="9312275" cy="3492103"/>
+          </a:xfrm>
+          <a:prstGeom prst="rect">
+            <a:avLst/>
+          </a:prstGeom>
+          <a:noFill/>
+          <a:ln>
+            <a:noFill/>
+          </a:ln>
+          <a:extLst>
+            <a:ext uri="{909E8E84-426E-40DD-AFC4-6F175D3DCCD1}">
+              <a14:hiddenFill xmlns:a14="http://schemas.microsoft.com/office/drawing/2010/main">
+                <a:solidFill>
+                  <a:schemeClr val="accent1"/>
+                </a:solidFill>
+              </a14:hiddenFill>
+            </a:ext>
+            <a:ext uri="{91240B29-F687-4F45-9708-019B960494DF}">
+              <a14:hiddenLine xmlns:a14="http://schemas.microsoft.com/office/drawing/2010/main" w="9525">
+                <a:solidFill>
+                  <a:schemeClr val="tx1"/>
+                </a:solidFill>
+                <a:miter lim="800000"/>
+                <a:headEnd/>
+                <a:tailEnd/>
+              </a14:hiddenLine>
+            </a:ext>
+          </a:extLst>
+        </p:spPr>
+      </p:pic>
+      <p:sp>
+        <p:nvSpPr>
+          <p:cNvPr id="23" name="Date Placeholder 9">
+            <a:extLst>
+              <a:ext uri="{FF2B5EF4-FFF2-40B4-BE49-F238E27FC236}">
+                <a16:creationId xmlns:a16="http://schemas.microsoft.com/office/drawing/2014/main" id="{82C78FE6-A666-B414-4483-5F9564CA3C02}"/>
+              </a:ext>
+            </a:extLst>
+          </p:cNvPr>
+          <p:cNvSpPr>
+            <a:spLocks noGrp="1"/>
+          </p:cNvSpPr>
+          <p:nvPr>
+            <p:ph type="dt" sz="half" idx="2"/>
+          </p:nvPr>
+        </p:nvSpPr>
+        <p:spPr>
+          <a:xfrm>
+            <a:off x="217598" y="6517037"/>
+            <a:ext cx="733317" cy="365125"/>
+          </a:xfrm>
+          <a:prstGeom prst="rect">
+            <a:avLst/>
+          </a:prstGeom>
+        </p:spPr>
+        <p:txBody>
+          <a:bodyPr vert="horz" lIns="91440" tIns="45720" rIns="91440" bIns="45720" rtlCol="0" anchor="ctr"/>
+          <a:lstStyle>
+            <a:lvl1pPr algn="l">
+              <a:defRPr sz="800">
+                <a:solidFill>
+                  <a:schemeClr val="bg1"/>
+                </a:solidFill>
+                <a:latin typeface="+mn-lt"/>
+              </a:defRPr>
+            </a:lvl1pPr>
+          </a:lstStyle>
+          <a:p>
+            <a:fld id="{3DF5C358-002F-4FFE-AE51-8D3FBE9A7FC8}" type="datetimeFigureOut">
+              <a:rPr lang="en-US" smtClean="0"/>
+              <a:pPr/>
+              <a:t>10/6/2026</a:t>
+            </a:fld>
+            <a:endParaRPr lang="en-US" dirty="0"/>
+          </a:p>
+        </p:txBody>
+      </p:sp>
+    </p:spTree>
+    <p:extLst>
+      <p:ext uri="{BB962C8B-B14F-4D97-AF65-F5344CB8AC3E}">
+        <p14:creationId xmlns:p14="http://schemas.microsoft.com/office/powerpoint/2010/main" val="1347308029"/>
+      </p:ext>
+    </p:extLst>
+  </p:cSld>
+  <p:clrMapOvr>
+    <a:masterClrMapping/>
+  </p:clrMapOvr>
+</p:sld>
+</file>
+
+<file path=ppt/slides/slide4.xml><?xml version="1.0" encoding="utf-8"?>
+<p:sld xmlns:a="http://schemas.openxmlformats.org/drawingml/2006/main" xmlns:r="http://schemas.openxmlformats.org/officeDocument/2006/relationships" xmlns:p="http://schemas.openxmlformats.org/presentationml/2006/main">
+  <p:cSld>
+    <p:spTree>
+      <p:nvGrpSpPr>
+        <p:cNvPr id="1" name=""/>
+        <p:cNvGrpSpPr/>
+        <p:nvPr/>
+      </p:nvGrpSpPr>
+      <p:grpSpPr>
+        <a:xfrm>
+          <a:off x="0" y="0"/>
+          <a:ext cx="0" cy="0"/>
+          <a:chOff x="0" y="0"/>
+          <a:chExt cx="0" cy="0"/>
+        </a:xfrm>
+      </p:grpSpPr>
+      <p:sp>
+        <p:nvSpPr>
+          <p:cNvPr id="2" name="Title 1">
+            <a:extLst>
+              <a:ext uri="{FF2B5EF4-FFF2-40B4-BE49-F238E27FC236}">
+                <a16:creationId xmlns:a16="http://schemas.microsoft.com/office/drawing/2014/main" id="{0406AECF-746F-7297-C12C-524ED3F3B138}"/>
+              </a:ext>
+            </a:extLst>
+          </p:cNvPr>
+          <p:cNvSpPr>
+            <a:spLocks noGrp="1"/>
+          </p:cNvSpPr>
+          <p:nvPr>
+            <p:ph type="title"/>
+          </p:nvPr>
+        </p:nvSpPr>
+        <p:spPr/>
+        <p:txBody>
+          <a:bodyPr/>
+          <a:lstStyle/>
+          <a:p>
+            <a:endParaRPr lang="en-US"/>
+          </a:p>
+        </p:txBody>
+      </p:sp>
+      <p:pic>
+        <p:nvPicPr>
+          <p:cNvPr id="8" name="Content Placeholder 7">
+            <a:extLst>
+              <a:ext uri="{FF2B5EF4-FFF2-40B4-BE49-F238E27FC236}">
+                <a16:creationId xmlns:a16="http://schemas.microsoft.com/office/drawing/2014/main" id="{132054DC-D8E4-F217-0C62-7D85B41FF752}"/>
+              </a:ext>
+            </a:extLst>
+          </p:cNvPr>
+          <p:cNvPicPr>
+            <a:picLocks noGrp="1" noChangeAspect="1"/>
+          </p:cNvPicPr>
+          <p:nvPr>
+            <p:ph idx="1"/>
+          </p:nvPr>
+        </p:nvPicPr>
+        <p:blipFill>
+          <a:blip>
+            <a:extLst>
+              <a:ext uri="{96DAC541-7B7A-43D3-8B79-37D633B846F1}">
+                <asvg:svgBlip xmlns:asvg="http://schemas.microsoft.com/office/drawing/2016/SVG/main" r:embed="rId2"/>
+              </a:ext>
+            </a:extLst>
+          </a:blip>
+          <a:stretch>
+            <a:fillRect/>
+          </a:stretch>
+        </p:blipFill>
+        <p:spPr bwMode="auto">
+          <a:xfrm>
+            <a:off x="1885950" y="1706563"/>
+            <a:ext cx="9090024" cy="4545012"/>
+          </a:xfrm>
+          <a:prstGeom prst="rect">
+            <a:avLst/>
+          </a:prstGeom>
+          <a:noFill/>
+          <a:ln>
+            <a:noFill/>
+          </a:ln>
+          <a:extLst>
+            <a:ext uri="{909E8E84-426E-40DD-AFC4-6F175D3DCCD1}">
+              <a14:hiddenFill xmlns:a14="http://schemas.microsoft.com/office/drawing/2010/main">
+                <a:solidFill>
+                  <a:schemeClr val="accent1"/>
+                </a:solidFill>
+              </a14:hiddenFill>
+            </a:ext>
+            <a:ext uri="{91240B29-F687-4F45-9708-019B960494DF}">
+              <a14:hiddenLine xmlns:a14="http://schemas.microsoft.com/office/drawing/2010/main" w="9525">
+                <a:solidFill>
+                  <a:schemeClr val="tx1"/>
+                </a:solidFill>
+                <a:miter lim="800000"/>
+                <a:headEnd/>
+                <a:tailEnd/>
+              </a14:hiddenLine>
+            </a:ext>
+          </a:extLst>
+        </p:spPr>
+      </p:pic>
+      <p:sp>
+        <p:nvSpPr>
+          <p:cNvPr id="4" name="Footer Placeholder 3">
+            <a:extLst>
+              <a:ext uri="{FF2B5EF4-FFF2-40B4-BE49-F238E27FC236}">
+                <a16:creationId xmlns:a16="http://schemas.microsoft.com/office/drawing/2014/main" id="{C94CA3DC-0419-B96F-45D7-1808A93308A7}"/>
+              </a:ext>
+            </a:extLst>
+          </p:cNvPr>
+          <p:cNvSpPr>
+            <a:spLocks noGrp="1"/>
+          </p:cNvSpPr>
+          <p:nvPr>
+            <p:ph type="ftr" sz="quarter" idx="10"/>
+          </p:nvPr>
+        </p:nvSpPr>
+        <p:spPr/>
+        <p:txBody>
+          <a:bodyPr/>
+          <a:lstStyle/>
+          <a:p>
+            <a:r>
+              <a:rPr lang="en-US" sz="800"/>
+              <a:t>A deconstructed comparison of DWM and LES wake aerodynamics</a:t>
+            </a:r>
+            <a:endParaRPr lang="en-GB" dirty="0"/>
+          </a:p>
+        </p:txBody>
+      </p:sp>
+      <p:sp>
+        <p:nvSpPr>
+          <p:cNvPr id="5" name="Slide Number Placeholder 4">
+            <a:extLst>
+              <a:ext uri="{FF2B5EF4-FFF2-40B4-BE49-F238E27FC236}">
+                <a16:creationId xmlns:a16="http://schemas.microsoft.com/office/drawing/2014/main" id="{4741FE69-652C-87DE-CEA7-27158B8255D3}"/>
+              </a:ext>
+            </a:extLst>
+          </p:cNvPr>
+          <p:cNvSpPr>
+            <a:spLocks noGrp="1"/>
+          </p:cNvSpPr>
+          <p:nvPr>
+            <p:ph type="sldNum" sz="quarter" idx="11"/>
+          </p:nvPr>
+        </p:nvSpPr>
+        <p:spPr/>
+        <p:txBody>
+          <a:bodyPr/>
+          <a:lstStyle/>
+          <a:p>
+            <a:fld id="{103EA872-A674-449B-A120-B97244F8E91D}" type="slidenum">
+              <a:rPr lang="en-GB" smtClean="0"/>
+              <a:pPr/>
+              <a:t>4</a:t>
+            </a:fld>
+            <a:endParaRPr lang="en-GB" dirty="0"/>
+          </a:p>
+        </p:txBody>
+      </p:sp>
+      <p:sp>
+        <p:nvSpPr>
+          <p:cNvPr id="6" name="Date Placeholder 5">
+            <a:extLst>
+              <a:ext uri="{FF2B5EF4-FFF2-40B4-BE49-F238E27FC236}">
+                <a16:creationId xmlns:a16="http://schemas.microsoft.com/office/drawing/2014/main" id="{DDDD185C-54EB-0951-C773-074165231DC6}"/>
+              </a:ext>
+            </a:extLst>
+          </p:cNvPr>
+          <p:cNvSpPr>
+            <a:spLocks noGrp="1"/>
+          </p:cNvSpPr>
+          <p:nvPr>
+            <p:ph type="dt" sz="half" idx="2"/>
+          </p:nvPr>
+        </p:nvSpPr>
+        <p:spPr/>
+        <p:txBody>
+          <a:bodyPr/>
+          <a:lstStyle/>
+          <a:p>
+            <a:fld id="{ABC5294D-B014-4D29-AA72-4A0BF09E1C4A}" type="datetime1">
+              <a:rPr lang="en-US" smtClean="0"/>
+              <a:t>10/6/2026</a:t>
+            </a:fld>
+            <a:endParaRPr lang="en-US" dirty="0"/>
+          </a:p>
+        </p:txBody>
+      </p:sp>
+    </p:spTree>
+    <p:extLst>
+      <p:ext uri="{BB962C8B-B14F-4D97-AF65-F5344CB8AC3E}">
+        <p14:creationId xmlns:p14="http://schemas.microsoft.com/office/powerpoint/2010/main" val="72060593"/>
+      </p:ext>
+    </p:extLst>
+  </p:cSld>
+  <p:clrMapOvr>
+    <a:masterClrMapping/>
+  </p:clrMapOvr>
+</p:sld>
+</file>
+
+<file path=ppt/slides/slide5.xml><?xml version="1.0" encoding="utf-8"?>
+<p:sld xmlns:a="http://schemas.openxmlformats.org/drawingml/2006/main" xmlns:r="http://schemas.openxmlformats.org/officeDocument/2006/relationships" xmlns:p="http://schemas.openxmlformats.org/presentationml/2006/main">
+  <p:cSld>
+    <p:spTree>
+      <p:nvGrpSpPr>
+        <p:cNvPr id="1" name=""/>
+        <p:cNvGrpSpPr/>
+        <p:nvPr/>
+      </p:nvGrpSpPr>
+      <p:grpSpPr>
+        <a:xfrm>
+          <a:off x="0" y="0"/>
+          <a:ext cx="0" cy="0"/>
+          <a:chOff x="0" y="0"/>
+          <a:chExt cx="0" cy="0"/>
+        </a:xfrm>
+      </p:grpSpPr>
+      <p:sp>
+        <p:nvSpPr>
+          <p:cNvPr id="2" name="Title 1">
+            <a:extLst>
+              <a:ext uri="{FF2B5EF4-FFF2-40B4-BE49-F238E27FC236}">
+                <a16:creationId xmlns:a16="http://schemas.microsoft.com/office/drawing/2014/main" id="{B3C86370-FB49-9955-657E-44133835ED8C}"/>
+              </a:ext>
+            </a:extLst>
+          </p:cNvPr>
+          <p:cNvSpPr>
+            <a:spLocks noGrp="1"/>
+          </p:cNvSpPr>
+          <p:nvPr>
+            <p:ph type="title"/>
+          </p:nvPr>
+        </p:nvSpPr>
+        <p:spPr/>
+        <p:txBody>
+          <a:bodyPr/>
+          <a:lstStyle/>
+          <a:p>
+            <a:endParaRPr lang="en-US"/>
+          </a:p>
+        </p:txBody>
+      </p:sp>
+      <p:sp>
+        <p:nvSpPr>
+          <p:cNvPr id="4" name="Footer Placeholder 3">
+            <a:extLst>
+              <a:ext uri="{FF2B5EF4-FFF2-40B4-BE49-F238E27FC236}">
+                <a16:creationId xmlns:a16="http://schemas.microsoft.com/office/drawing/2014/main" id="{D33133D0-575F-87D0-6120-C35AACAAA23A}"/>
+              </a:ext>
+            </a:extLst>
+          </p:cNvPr>
+          <p:cNvSpPr>
+            <a:spLocks noGrp="1"/>
+          </p:cNvSpPr>
+          <p:nvPr>
+            <p:ph type="ftr" sz="quarter" idx="10"/>
+          </p:nvPr>
+        </p:nvSpPr>
+        <p:spPr/>
+        <p:txBody>
+          <a:bodyPr/>
+          <a:lstStyle/>
+          <a:p>
+            <a:r>
+              <a:rPr lang="en-US" sz="800"/>
+              <a:t>A deconstructed comparison of DWM and LES wake aerodynamics</a:t>
+            </a:r>
+            <a:endParaRPr lang="en-GB" dirty="0"/>
+          </a:p>
+        </p:txBody>
+      </p:sp>
+      <p:sp>
+        <p:nvSpPr>
+          <p:cNvPr id="5" name="Slide Number Placeholder 4">
+            <a:extLst>
+              <a:ext uri="{FF2B5EF4-FFF2-40B4-BE49-F238E27FC236}">
+                <a16:creationId xmlns:a16="http://schemas.microsoft.com/office/drawing/2014/main" id="{19A55D8A-A323-FAE3-DE97-309753485243}"/>
+              </a:ext>
+            </a:extLst>
+          </p:cNvPr>
+          <p:cNvSpPr>
+            <a:spLocks noGrp="1"/>
+          </p:cNvSpPr>
+          <p:nvPr>
+            <p:ph type="sldNum" sz="quarter" idx="11"/>
+          </p:nvPr>
+        </p:nvSpPr>
+        <p:spPr/>
+        <p:txBody>
+          <a:bodyPr/>
+          <a:lstStyle/>
+          <a:p>
+            <a:fld id="{103EA872-A674-449B-A120-B97244F8E91D}" type="slidenum">
+              <a:rPr lang="en-GB" smtClean="0"/>
+              <a:pPr/>
+              <a:t>5</a:t>
+            </a:fld>
+            <a:endParaRPr lang="en-GB" dirty="0"/>
+          </a:p>
+        </p:txBody>
+      </p:sp>
+      <p:sp>
+        <p:nvSpPr>
+          <p:cNvPr id="6" name="Date Placeholder 5">
+            <a:extLst>
+              <a:ext uri="{FF2B5EF4-FFF2-40B4-BE49-F238E27FC236}">
+                <a16:creationId xmlns:a16="http://schemas.microsoft.com/office/drawing/2014/main" id="{603D0CAB-C913-5A94-5886-FB2E29391F88}"/>
+              </a:ext>
+            </a:extLst>
+          </p:cNvPr>
+          <p:cNvSpPr>
+            <a:spLocks noGrp="1"/>
+          </p:cNvSpPr>
+          <p:nvPr>
+            <p:ph type="dt" sz="half" idx="2"/>
+          </p:nvPr>
+        </p:nvSpPr>
+        <p:spPr/>
+        <p:txBody>
+          <a:bodyPr/>
+          <a:lstStyle/>
+          <a:p>
+            <a:fld id="{EB050DF7-81F0-48EF-8D00-12E52D675DC3}" type="datetime1">
+              <a:rPr lang="en-US" smtClean="0"/>
+              <a:t>10/6/2026</a:t>
+            </a:fld>
+            <a:endParaRPr lang="en-US" dirty="0"/>
+          </a:p>
+        </p:txBody>
+      </p:sp>
+      <p:sp>
+        <p:nvSpPr>
+          <p:cNvPr id="9" name="Content Placeholder 8">
+            <a:extLst>
+              <a:ext uri="{FF2B5EF4-FFF2-40B4-BE49-F238E27FC236}">
+                <a16:creationId xmlns:a16="http://schemas.microsoft.com/office/drawing/2014/main" id="{E6743921-45D1-1BDE-5B11-CC46367BB2D4}"/>
+              </a:ext>
+            </a:extLst>
+          </p:cNvPr>
+          <p:cNvSpPr>
+            <a:spLocks noGrp="1"/>
+          </p:cNvSpPr>
+          <p:nvPr>
+            <p:ph idx="1"/>
+          </p:nvPr>
+        </p:nvSpPr>
+        <p:spPr/>
+        <p:txBody>
+          <a:bodyPr/>
+          <a:lstStyle/>
+          <a:p>
+            <a:endParaRPr lang="en-US"/>
+          </a:p>
+        </p:txBody>
+      </p:sp>
+    </p:spTree>
+    <p:extLst>
+      <p:ext uri="{BB962C8B-B14F-4D97-AF65-F5344CB8AC3E}">
+        <p14:creationId xmlns:p14="http://schemas.microsoft.com/office/powerpoint/2010/main" val="2945351217"/>
+      </p:ext>
+    </p:extLst>
+  </p:cSld>
+  <p:clrMapOvr>
+    <a:masterClrMapping/>
+  </p:clrMapOvr>
+</p:sld>
+</file>
+
+<file path=ppt/slides/slide6.xml><?xml version="1.0" encoding="utf-8"?>
 <p:sld xmlns:a="http://schemas.openxmlformats.org/drawingml/2006/main" xmlns:r="http://schemas.openxmlformats.org/officeDocument/2006/relationships" xmlns:p="http://schemas.openxmlformats.org/presentationml/2006/main">
   <p:cSld>
     <p:bg>
@@ -10564,8 +11356,8 @@
           <a:lstStyle/>
           <a:p>
             <a:r>
-              <a:rPr lang="en-GB"/>
-              <a:t>Footer</a:t>
+              <a:rPr lang="en-US" sz="800" dirty="0"/>
+              <a:t>A deconstructed comparison of DWM and LES wake aerodynamics</a:t>
             </a:r>
             <a:endParaRPr lang="en-GB" dirty="0"/>
           </a:p>
@@ -10595,7 +11387,7 @@
             <a:fld id="{24C8C45C-947F-4981-8B3F-4F32E973C901}" type="slidenum">
               <a:rPr lang="en-GB" smtClean="0"/>
               <a:pPr/>
-              <a:t>3</a:t>
+              <a:t>6</a:t>
             </a:fld>
             <a:endParaRPr lang="en-GB" dirty="0"/>
           </a:p>
@@ -10848,34 +11640,6 @@
                 <a:schemeClr val="accent6"/>
               </a:solidFill>
             </a:endParaRPr>
-          </a:p>
-        </p:txBody>
-      </p:sp>
-      <p:sp>
-        <p:nvSpPr>
-          <p:cNvPr id="4" name="Date Placeholder 3">
-            <a:extLst>
-              <a:ext uri="{FF2B5EF4-FFF2-40B4-BE49-F238E27FC236}">
-                <a16:creationId xmlns:a16="http://schemas.microsoft.com/office/drawing/2014/main" id="{C5BA2C2A-0C6F-FB40-DC52-335D1DF553B3}"/>
-              </a:ext>
-            </a:extLst>
-          </p:cNvPr>
-          <p:cNvSpPr>
-            <a:spLocks noGrp="1"/>
-          </p:cNvSpPr>
-          <p:nvPr>
-            <p:ph type="dt" sz="half" idx="18"/>
-          </p:nvPr>
-        </p:nvSpPr>
-        <p:spPr/>
-        <p:txBody>
-          <a:bodyPr/>
-          <a:lstStyle/>
-          <a:p>
-            <a:r>
-              <a:rPr lang="en-GB"/>
-              <a:t>Date</a:t>
-            </a:r>
           </a:p>
         </p:txBody>
       </p:sp>
@@ -11115,6 +11879,53 @@
           </a:p>
         </p:txBody>
       </p:sp>
+      <p:sp>
+        <p:nvSpPr>
+          <p:cNvPr id="9" name="Date Placeholder 9">
+            <a:extLst>
+              <a:ext uri="{FF2B5EF4-FFF2-40B4-BE49-F238E27FC236}">
+                <a16:creationId xmlns:a16="http://schemas.microsoft.com/office/drawing/2014/main" id="{BCC8F361-2630-973B-06E4-4ACD23977650}"/>
+              </a:ext>
+            </a:extLst>
+          </p:cNvPr>
+          <p:cNvSpPr>
+            <a:spLocks noGrp="1"/>
+          </p:cNvSpPr>
+          <p:nvPr>
+            <p:ph type="dt" sz="half" idx="2"/>
+          </p:nvPr>
+        </p:nvSpPr>
+        <p:spPr>
+          <a:xfrm>
+            <a:off x="217598" y="6517037"/>
+            <a:ext cx="733317" cy="365125"/>
+          </a:xfrm>
+          <a:prstGeom prst="rect">
+            <a:avLst/>
+          </a:prstGeom>
+        </p:spPr>
+        <p:txBody>
+          <a:bodyPr vert="horz" lIns="91440" tIns="45720" rIns="91440" bIns="45720" rtlCol="0" anchor="ctr"/>
+          <a:lstStyle>
+            <a:lvl1pPr algn="l">
+              <a:defRPr sz="800">
+                <a:solidFill>
+                  <a:schemeClr val="bg1"/>
+                </a:solidFill>
+                <a:latin typeface="+mn-lt"/>
+              </a:defRPr>
+            </a:lvl1pPr>
+          </a:lstStyle>
+          <a:p>
+            <a:fld id="{3DF5C358-002F-4FFE-AE51-8D3FBE9A7FC8}" type="datetimeFigureOut">
+              <a:rPr lang="en-US" smtClean="0"/>
+              <a:pPr/>
+              <a:t>10/6/2026</a:t>
+            </a:fld>
+            <a:endParaRPr lang="en-US" dirty="0"/>
+          </a:p>
+        </p:txBody>
+      </p:sp>
     </p:spTree>
     <p:custDataLst>
       <p:custData r:id="rId1"/>
@@ -11132,7 +11943,7 @@
 </p:sld>
 </file>
 
-<file path=ppt/slides/slide4.xml><?xml version="1.0" encoding="utf-8"?>
+<file path=ppt/slides/slide7.xml><?xml version="1.0" encoding="utf-8"?>
 <p:sld xmlns:a="http://schemas.openxmlformats.org/drawingml/2006/main" xmlns:r="http://schemas.openxmlformats.org/officeDocument/2006/relationships" xmlns:p="http://schemas.openxmlformats.org/presentationml/2006/main">
   <p:cSld>
     <p:spTree>
@@ -11227,8 +12038,8 @@
           <a:lstStyle/>
           <a:p>
             <a:r>
-              <a:rPr lang="en-GB"/>
-              <a:t>Footer</a:t>
+              <a:rPr lang="en-US" sz="800" dirty="0"/>
+              <a:t>A deconstructed comparison of DWM and LES wake aerodynamics</a:t>
             </a:r>
             <a:endParaRPr lang="en-GB" dirty="0"/>
           </a:p>
@@ -11258,7 +12069,7 @@
             <a:fld id="{103EA872-A674-449B-A120-B97244F8E91D}" type="slidenum">
               <a:rPr lang="en-GB" smtClean="0"/>
               <a:pPr/>
-              <a:t>4</a:t>
+              <a:t>7</a:t>
             </a:fld>
             <a:endParaRPr lang="en-GB" dirty="0"/>
           </a:p>
@@ -11266,10 +12077,10 @@
       </p:sp>
       <p:sp>
         <p:nvSpPr>
-          <p:cNvPr id="6" name="Date Placeholder 5">
+          <p:cNvPr id="7" name="Date Placeholder 9">
             <a:extLst>
               <a:ext uri="{FF2B5EF4-FFF2-40B4-BE49-F238E27FC236}">
-                <a16:creationId xmlns:a16="http://schemas.microsoft.com/office/drawing/2014/main" id="{917EE326-536D-AE10-DCAF-F72F67DC87F8}"/>
+                <a16:creationId xmlns:a16="http://schemas.microsoft.com/office/drawing/2014/main" id="{82D8FECE-C180-F0A0-DFDA-2356AC215DDD}"/>
               </a:ext>
             </a:extLst>
           </p:cNvPr>
@@ -11277,18 +12088,37 @@
             <a:spLocks noGrp="1"/>
           </p:cNvSpPr>
           <p:nvPr>
-            <p:ph type="dt" sz="half" idx="12"/>
+            <p:ph type="dt" sz="half" idx="2"/>
           </p:nvPr>
         </p:nvSpPr>
-        <p:spPr/>
+        <p:spPr>
+          <a:xfrm>
+            <a:off x="217598" y="6517037"/>
+            <a:ext cx="733317" cy="365125"/>
+          </a:xfrm>
+          <a:prstGeom prst="rect">
+            <a:avLst/>
+          </a:prstGeom>
+        </p:spPr>
         <p:txBody>
-          <a:bodyPr/>
-          <a:lstStyle/>
-          <a:p>
-            <a:r>
-              <a:rPr lang="en-GB"/>
-              <a:t>Date</a:t>
-            </a:r>
+          <a:bodyPr vert="horz" lIns="91440" tIns="45720" rIns="91440" bIns="45720" rtlCol="0" anchor="ctr"/>
+          <a:lstStyle>
+            <a:lvl1pPr algn="l">
+              <a:defRPr sz="800">
+                <a:solidFill>
+                  <a:schemeClr val="bg1"/>
+                </a:solidFill>
+                <a:latin typeface="+mn-lt"/>
+              </a:defRPr>
+            </a:lvl1pPr>
+          </a:lstStyle>
+          <a:p>
+            <a:fld id="{3DF5C358-002F-4FFE-AE51-8D3FBE9A7FC8}" type="datetimeFigureOut">
+              <a:rPr lang="en-US" smtClean="0"/>
+              <a:pPr/>
+              <a:t>10/6/2026</a:t>
+            </a:fld>
+            <a:endParaRPr lang="en-US" dirty="0"/>
           </a:p>
         </p:txBody>
       </p:sp>
@@ -12260,35 +13090,42 @@
 </file>
 
 <file path=customXml/item1.xml><?xml version="1.0" encoding="utf-8"?>
+<p:properties xmlns:p="http://schemas.microsoft.com/office/2006/metadata/properties" xmlns:xsi="http://www.w3.org/2001/XMLSchema-instance" xmlns:pc="http://schemas.microsoft.com/office/infopath/2007/PartnerControls">
+  <documentManagement/>
+</p:properties>
+</file>
+
+<file path=customXml/item10.xml><?xml version="1.0" encoding="utf-8"?>
+<TemplafySlideTemplateConfiguration><![CDATA[{"documentContentValidatorConfiguration":{"enableDocumentContentValidator":false,"documentContentValidatorVersion":0},"elementsMetadata":[],"slideId":"637582373565786322","enableDocumentContentUpdater":true,"version":"1.2"}]]></TemplafySlideTemplateConfiguration>
+</file>
+
+<file path=customXml/item11.xml><?xml version="1.0" encoding="utf-8"?>
 <TemplafySlideFormConfiguration><![CDATA[{"formFields":[],"formDataEntries":[]}]]></TemplafySlideFormConfiguration>
 </file>
 
-<file path=customXml/item10.xml><?xml version="1.0" encoding="utf-8"?>
-<TemplafySlideFormConfiguration><![CDATA[{"formFields":[],"formDataEntries":[]}]]></TemplafySlideFormConfiguration>
+<file path=customXml/item12.xml><?xml version="1.0" encoding="utf-8"?>
+<TemplafyFormConfiguration><![CDATA[{"formFields":[{"required":false,"helpTexts":{"prefix":"","postfix":""},"spacing":{},"type":"datePicker","name":"Date","label":"Date","fullyQualifiedName":"Date"},{"required":false,"placeholder":"","lines":0,"helpTexts":{"prefix":"","postfix":""},"spacing":{},"type":"textBox","name":"PresentationTitle","label":"Presentation title","fullyQualifiedName":"PresentationTitle"}],"formDataEntries":[]}]]></TemplafyFormConfiguration>
 </file>
 
-<file path=customXml/item11.xml><?xml version="1.0" encoding="utf-8"?>
+<file path=customXml/item13.xml><?xml version="1.0" encoding="utf-8"?>
+<TemplafySlideTemplateConfiguration><![CDATA[{"documentContentValidatorConfiguration":{"enableDocumentContentValidator":false,"documentContentValidatorVersion":0},"elementsMetadata":[],"slideId":"636822015789305408","enableDocumentContentUpdater":true,"version":"1.2"}]]></TemplafySlideTemplateConfiguration>
+</file>
+
+<file path=customXml/item14.xml><?xml version="1.0" encoding="utf-8"?>
+<?mso-contentType ?>
+<FormTemplates xmlns="http://schemas.microsoft.com/sharepoint/v3/contenttype/forms">
+  <Display>DocumentLibraryForm</Display>
+  <Edit>DocumentLibraryForm</Edit>
+  <New>DocumentLibraryForm</New>
+</FormTemplates>
+</file>
+
+<file path=customXml/item15.xml><?xml version="1.0" encoding="utf-8"?>
 <TemplafySlideTemplateConfiguration><![CDATA[{"documentContentValidatorConfiguration":{"enableDocumentContentValidator":false,"documentContentValidatorVersion":0},"elementsMetadata":[],"slideId":"637582373565786322","enableDocumentContentUpdater":true,"version":"1.2"}]]></TemplafySlideTemplateConfiguration>
 </file>
 
-<file path=customXml/item12.xml><?xml version="1.0" encoding="utf-8"?>
+<file path=customXml/item2.xml><?xml version="1.0" encoding="utf-8"?>
 <TemplafySlideFormConfiguration><![CDATA[{"formFields":[],"formDataEntries":[]}]]></TemplafySlideFormConfiguration>
-</file>
-
-<file path=customXml/item13.xml><?xml version="1.0" encoding="utf-8"?>
-<TemplafySlideTemplateConfiguration><![CDATA[{"documentContentValidatorConfiguration":{"enableDocumentContentValidator":false,"documentContentValidatorVersion":0},"elementsMetadata":[],"slideId":"637582373565786322","enableDocumentContentUpdater":true,"version":"1.2"}]]></TemplafySlideTemplateConfiguration>
-</file>
-
-<file path=customXml/item14.xml><?xml version="1.0" encoding="utf-8"?>
-<TemplafySlideTemplateConfiguration><![CDATA[{"documentContentValidatorConfiguration":{"enableDocumentContentValidator":false,"documentContentValidatorVersion":0},"elementsMetadata":[],"slideId":"637582373565786322","enableDocumentContentUpdater":true,"version":"1.2"}]]></TemplafySlideTemplateConfiguration>
-</file>
-
-<file path=customXml/item15.xml><?xml version="1.0" encoding="utf-8"?>
-<TemplafySlideFormConfiguration><![CDATA[{"formFields":[],"formDataEntries":[]}]]></TemplafySlideFormConfiguration>
-</file>
-
-<file path=customXml/item2.xml><?xml version="1.0" encoding="utf-8"?>
-<TemplafyTemplateConfiguration><![CDATA[{"elementsMetadata":[{"type":"shape","id":"760c0b01-e6e8-4844-b6e1-1dc9fa2aa3a0","elementConfiguration":{"binding":"UserProfile.Offices.Workarea_{{DocumentLanguage}}","disableUpdates":false,"type":"text"}},{"type":"shape","id":"d52388ce-2b60-421d-b542-b927e7f7ca5d","elementConfiguration":{"format":"{{DateFormats.GeneralDate}}","binding":"Form.Date","disableUpdates":false,"type":"date"}},{"type":"shape","id":"19920dab-3faa-4eb9-b064-a1f7031a4d5a","elementConfiguration":{"binding":"Form.PresentationTitle","disableUpdates":false,"type":"text"}}],"transformationConfigurations":[{"language":"{{DocumentLanguage}}","disableUpdates":false,"type":"proofingLanguage"}],"templateName":"DTU Wind Energy Template","templateDescription":"","enableDocumentContentUpdater":true,"version":"1.2"}]]></TemplafyTemplateConfiguration>
 </file>
 
 <file path=customXml/item3.xml><?xml version="1.0" encoding="utf-8"?>
@@ -12467,22 +13304,15 @@
 </file>
 
 <file path=customXml/item5.xml><?xml version="1.0" encoding="utf-8"?>
-<TemplafyFormConfiguration><![CDATA[{"formFields":[{"required":false,"helpTexts":{"prefix":"","postfix":""},"spacing":{},"type":"datePicker","name":"Date","label":"Date","fullyQualifiedName":"Date"},{"required":false,"placeholder":"","lines":0,"helpTexts":{"prefix":"","postfix":""},"spacing":{},"type":"textBox","name":"PresentationTitle","label":"Presentation title","fullyQualifiedName":"PresentationTitle"}],"formDataEntries":[]}]]></TemplafyFormConfiguration>
+<TemplafySlideFormConfiguration><![CDATA[{"formFields":[],"formDataEntries":[]}]]></TemplafySlideFormConfiguration>
 </file>
 
 <file path=customXml/item6.xml><?xml version="1.0" encoding="utf-8"?>
-<p:properties xmlns:p="http://schemas.microsoft.com/office/2006/metadata/properties" xmlns:xsi="http://www.w3.org/2001/XMLSchema-instance" xmlns:pc="http://schemas.microsoft.com/office/infopath/2007/PartnerControls">
-  <documentManagement/>
-</p:properties>
+<TemplafySlideTemplateConfiguration><![CDATA[{"documentContentValidatorConfiguration":{"enableDocumentContentValidator":false,"documentContentValidatorVersion":0},"elementsMetadata":[],"slideId":"637582373565786322","enableDocumentContentUpdater":true,"version":"1.2"}]]></TemplafySlideTemplateConfiguration>
 </file>
 
 <file path=customXml/item7.xml><?xml version="1.0" encoding="utf-8"?>
-<?mso-contentType ?>
-<FormTemplates xmlns="http://schemas.microsoft.com/sharepoint/v3/contenttype/forms">
-  <Display>DocumentLibraryForm</Display>
-  <Edit>DocumentLibraryForm</Edit>
-  <New>DocumentLibraryForm</New>
-</FormTemplates>
+<TemplafySlideFormConfiguration><![CDATA[{"formFields":[],"formDataEntries":[]}]]></TemplafySlideFormConfiguration>
 </file>
 
 <file path=customXml/item8.xml><?xml version="1.0" encoding="utf-8"?>
@@ -12490,53 +13320,58 @@
 </file>
 
 <file path=customXml/item9.xml><?xml version="1.0" encoding="utf-8"?>
-<TemplafySlideTemplateConfiguration><![CDATA[{"documentContentValidatorConfiguration":{"enableDocumentContentValidator":false,"documentContentValidatorVersion":0},"elementsMetadata":[],"slideId":"636822015789305408","enableDocumentContentUpdater":true,"version":"1.2"}]]></TemplafySlideTemplateConfiguration>
+<TemplafyTemplateConfiguration><![CDATA[{"elementsMetadata":[{"type":"shape","id":"760c0b01-e6e8-4844-b6e1-1dc9fa2aa3a0","elementConfiguration":{"binding":"UserProfile.Offices.Workarea_{{DocumentLanguage}}","disableUpdates":false,"type":"text"}},{"type":"shape","id":"d52388ce-2b60-421d-b542-b927e7f7ca5d","elementConfiguration":{"format":"{{DateFormats.GeneralDate}}","binding":"Form.Date","disableUpdates":false,"type":"date"}},{"type":"shape","id":"19920dab-3faa-4eb9-b064-a1f7031a4d5a","elementConfiguration":{"binding":"Form.PresentationTitle","disableUpdates":false,"type":"text"}}],"transformationConfigurations":[{"language":"{{DocumentLanguage}}","disableUpdates":false,"type":"proofingLanguage"}],"templateName":"DTU Wind Energy Template","templateDescription":"","enableDocumentContentUpdater":true,"version":"1.2"}]]></TemplafyTemplateConfiguration>
 </file>
 
 <file path=customXml/itemProps1.xml><?xml version="1.0" encoding="utf-8"?>
-<ds:datastoreItem xmlns:ds="http://schemas.openxmlformats.org/officeDocument/2006/customXml" ds:itemID="{256B63E5-69B6-464D-863A-E47835EE7289}">
-  <ds:schemaRefs/>
+<ds:datastoreItem xmlns:ds="http://schemas.openxmlformats.org/officeDocument/2006/customXml" ds:itemID="{AF32439C-8EF2-469F-A487-C82C55E480DE}">
+  <ds:schemaRefs>
+    <ds:schemaRef ds:uri="http://schemas.microsoft.com/office/2006/metadata/properties"/>
+    <ds:schemaRef ds:uri="http://schemas.microsoft.com/office/infopath/2007/PartnerControls"/>
+  </ds:schemaRefs>
 </ds:datastoreItem>
 </file>
 
 <file path=customXml/itemProps10.xml><?xml version="1.0" encoding="utf-8"?>
-<ds:datastoreItem xmlns:ds="http://schemas.openxmlformats.org/officeDocument/2006/customXml" ds:itemID="{89E65983-BEBD-4684-8266-29F51A82FD68}">
+<ds:datastoreItem xmlns:ds="http://schemas.openxmlformats.org/officeDocument/2006/customXml" ds:itemID="{0A0F7F37-D167-4B30-B1F7-9A6095DD8E5E}">
   <ds:schemaRefs/>
 </ds:datastoreItem>
 </file>
 
 <file path=customXml/itemProps11.xml><?xml version="1.0" encoding="utf-8"?>
+<ds:datastoreItem xmlns:ds="http://schemas.openxmlformats.org/officeDocument/2006/customXml" ds:itemID="{F5CD6E9F-EB95-4B70-B601-F184015A4F9D}">
+  <ds:schemaRefs/>
+</ds:datastoreItem>
+</file>
+
+<file path=customXml/itemProps12.xml><?xml version="1.0" encoding="utf-8"?>
+<ds:datastoreItem xmlns:ds="http://schemas.openxmlformats.org/officeDocument/2006/customXml" ds:itemID="{C086A146-0E09-4AA0-A3DC-33B2C18DA71A}">
+  <ds:schemaRefs/>
+</ds:datastoreItem>
+</file>
+
+<file path=customXml/itemProps13.xml><?xml version="1.0" encoding="utf-8"?>
+<ds:datastoreItem xmlns:ds="http://schemas.openxmlformats.org/officeDocument/2006/customXml" ds:itemID="{B917EF7A-B11F-4137-A061-E3AFCEC45668}">
+  <ds:schemaRefs/>
+</ds:datastoreItem>
+</file>
+
+<file path=customXml/itemProps14.xml><?xml version="1.0" encoding="utf-8"?>
+<ds:datastoreItem xmlns:ds="http://schemas.openxmlformats.org/officeDocument/2006/customXml" ds:itemID="{130D490B-E977-43FF-A2D1-8C2447D6F702}">
+  <ds:schemaRefs>
+    <ds:schemaRef ds:uri="http://schemas.microsoft.com/sharepoint/v3/contenttype/forms"/>
+  </ds:schemaRefs>
+</ds:datastoreItem>
+</file>
+
+<file path=customXml/itemProps15.xml><?xml version="1.0" encoding="utf-8"?>
 <ds:datastoreItem xmlns:ds="http://schemas.openxmlformats.org/officeDocument/2006/customXml" ds:itemID="{747FA701-153C-414F-9076-93D6EB8F30A9}">
   <ds:schemaRefs/>
 </ds:datastoreItem>
 </file>
 
-<file path=customXml/itemProps12.xml><?xml version="1.0" encoding="utf-8"?>
-<ds:datastoreItem xmlns:ds="http://schemas.openxmlformats.org/officeDocument/2006/customXml" ds:itemID="{F5CD6E9F-EB95-4B70-B601-F184015A4F9D}">
-  <ds:schemaRefs/>
-</ds:datastoreItem>
-</file>
-
-<file path=customXml/itemProps13.xml><?xml version="1.0" encoding="utf-8"?>
-<ds:datastoreItem xmlns:ds="http://schemas.openxmlformats.org/officeDocument/2006/customXml" ds:itemID="{9264A7C6-73F2-4A78-AE58-B921BC9D921C}">
-  <ds:schemaRefs/>
-</ds:datastoreItem>
-</file>
-
-<file path=customXml/itemProps14.xml><?xml version="1.0" encoding="utf-8"?>
-<ds:datastoreItem xmlns:ds="http://schemas.openxmlformats.org/officeDocument/2006/customXml" ds:itemID="{0A0F7F37-D167-4B30-B1F7-9A6095DD8E5E}">
-  <ds:schemaRefs/>
-</ds:datastoreItem>
-</file>
-
-<file path=customXml/itemProps15.xml><?xml version="1.0" encoding="utf-8"?>
-<ds:datastoreItem xmlns:ds="http://schemas.openxmlformats.org/officeDocument/2006/customXml" ds:itemID="{27900B32-6883-412F-8FAC-916A5B87173E}">
-  <ds:schemaRefs/>
-</ds:datastoreItem>
-</file>
-
 <file path=customXml/itemProps2.xml><?xml version="1.0" encoding="utf-8"?>
-<ds:datastoreItem xmlns:ds="http://schemas.openxmlformats.org/officeDocument/2006/customXml" ds:itemID="{1334258C-C3E7-4029-A615-C886A240FB15}">
+<ds:datastoreItem xmlns:ds="http://schemas.openxmlformats.org/officeDocument/2006/customXml" ds:itemID="{09A4C5C1-E379-42C2-9CE4-96EAD0C517EB}">
   <ds:schemaRefs/>
 </ds:datastoreItem>
 </file>
@@ -12561,31 +13396,26 @@
 </file>
 
 <file path=customXml/itemProps4.xml><?xml version="1.0" encoding="utf-8"?>
-<ds:datastoreItem xmlns:ds="http://schemas.openxmlformats.org/officeDocument/2006/customXml" ds:itemID="{09A4C5C1-E379-42C2-9CE4-96EAD0C517EB}">
+<ds:datastoreItem xmlns:ds="http://schemas.openxmlformats.org/officeDocument/2006/customXml" ds:itemID="{89E65983-BEBD-4684-8266-29F51A82FD68}">
   <ds:schemaRefs/>
 </ds:datastoreItem>
 </file>
 
 <file path=customXml/itemProps5.xml><?xml version="1.0" encoding="utf-8"?>
-<ds:datastoreItem xmlns:ds="http://schemas.openxmlformats.org/officeDocument/2006/customXml" ds:itemID="{C086A146-0E09-4AA0-A3DC-33B2C18DA71A}">
+<ds:datastoreItem xmlns:ds="http://schemas.openxmlformats.org/officeDocument/2006/customXml" ds:itemID="{256B63E5-69B6-464D-863A-E47835EE7289}">
   <ds:schemaRefs/>
 </ds:datastoreItem>
 </file>
 
 <file path=customXml/itemProps6.xml><?xml version="1.0" encoding="utf-8"?>
-<ds:datastoreItem xmlns:ds="http://schemas.openxmlformats.org/officeDocument/2006/customXml" ds:itemID="{AF32439C-8EF2-469F-A487-C82C55E480DE}">
-  <ds:schemaRefs>
-    <ds:schemaRef ds:uri="http://schemas.microsoft.com/office/2006/metadata/properties"/>
-    <ds:schemaRef ds:uri="http://schemas.microsoft.com/office/infopath/2007/PartnerControls"/>
-  </ds:schemaRefs>
+<ds:datastoreItem xmlns:ds="http://schemas.openxmlformats.org/officeDocument/2006/customXml" ds:itemID="{9264A7C6-73F2-4A78-AE58-B921BC9D921C}">
+  <ds:schemaRefs/>
 </ds:datastoreItem>
 </file>
 
 <file path=customXml/itemProps7.xml><?xml version="1.0" encoding="utf-8"?>
-<ds:datastoreItem xmlns:ds="http://schemas.openxmlformats.org/officeDocument/2006/customXml" ds:itemID="{130D490B-E977-43FF-A2D1-8C2447D6F702}">
-  <ds:schemaRefs>
-    <ds:schemaRef ds:uri="http://schemas.microsoft.com/sharepoint/v3/contenttype/forms"/>
-  </ds:schemaRefs>
+<ds:datastoreItem xmlns:ds="http://schemas.openxmlformats.org/officeDocument/2006/customXml" ds:itemID="{27900B32-6883-412F-8FAC-916A5B87173E}">
+  <ds:schemaRefs/>
 </ds:datastoreItem>
 </file>
 
@@ -12596,13 +13426,13 @@
 </file>
 
 <file path=customXml/itemProps9.xml><?xml version="1.0" encoding="utf-8"?>
-<ds:datastoreItem xmlns:ds="http://schemas.openxmlformats.org/officeDocument/2006/customXml" ds:itemID="{B917EF7A-B11F-4137-A061-E3AFCEC45668}">
+<ds:datastoreItem xmlns:ds="http://schemas.openxmlformats.org/officeDocument/2006/customXml" ds:itemID="{1334258C-C3E7-4029-A615-C886A240FB15}">
   <ds:schemaRefs/>
 </ds:datastoreItem>
 </file>
 
 <file path=docMetadata/LabelInfo.xml><?xml version="1.0" encoding="utf-8"?>
 <clbl:labelList xmlns:clbl="http://schemas.microsoft.com/office/2020/mipLabelMetadata">
-  <clbl:label id="{35c15001-c8e1-4e59-97bd-905e2080daab}" enabled="1" method="Standard" siteId="{c0701940-7b3f-4116-a59f-159078bc3c63}" contentBits="2" removed="0"/>
+  <clbl:label id="{c54a7a20-be22-4e5c-97bd-277f45e221d0}" enabled="1" method="Privileged" siteId="{c0701940-7b3f-4116-a59f-159078bc3c63}" contentBits="2" removed="0"/>
 </clbl:labelList>
 </file>
</xml_diff>